<commit_message>
Prezentācija: cilvēka pieņemšanas tests 6. un 10. slaidā
Co-Authored-By: Claude Opus 5.5 <noreply@anthropic.com>
</commit_message>
<xml_diff>
--- a/iesniegumi/docs/prezentacija.pptx
+++ b/iesniegumi/docs/prezentacija.pptx
@@ -120,40 +120,40 @@
   <p:extLst>
     <p:ext uri="{521415D9-36F7-43E2-AB2F-B90AF26B5E84}">
       <p14:sectionLst xmlns:p14="http://schemas.microsoft.com/office/powerpoint/2010/main">
-        <p14:section name="Ievads" id="{1a26ba1f-1f24-02cf-ba20-800d81422918}">
+        <p14:section name="Ievads" id="{fcc6d81b-b54b-9dd6-e89c-eeef641d5d88}">
           <p14:sldIdLst>
             <p14:sldId id="256"/>
             <p14:sldId id="257"/>
             <p14:sldId id="258"/>
           </p14:sldIdLst>
         </p14:section>
-        <p14:section name="Process" id="{cac39f3c-dadf-20e1-950d-4d59a1094025}">
+        <p14:section name="Process" id="{8b055588-f232-f046-0693-639355102d25}">
           <p14:sldIdLst>
             <p14:sldId id="259"/>
             <p14:sldId id="260"/>
             <p14:sldId id="261"/>
           </p14:sldIdLst>
         </p14:section>
-        <p14:section name="Rezultāts" id="{b3652cb1-b7a2-2995-4f86-9dbe4094e99e}">
+        <p14:section name="Rezultāts" id="{49d2a789-e60d-084a-1720-7130716c8814}">
           <p14:sldIdLst>
             <p14:sldId id="262"/>
             <p14:sldId id="263"/>
             <p14:sldId id="264"/>
           </p14:sldIdLst>
         </p14:section>
-        <p14:section name="Pieejamība" id="{7c6032b3-1702-ae61-d8ab-1a81baf94a78}">
+        <p14:section name="Pieejamība" id="{c41a134c-66be-e188-ea3e-46bb181e4ccd}">
           <p14:sldIdLst>
             <p14:sldId id="265"/>
             <p14:sldId id="266"/>
           </p14:sldIdLst>
         </p14:section>
-        <p14:section name="MI riski" id="{b8601013-d5fb-629d-f7d7-80d55bf56acd}">
+        <p14:section name="MI riski" id="{574d9082-5e71-3903-c303-7573bc793a05}">
           <p14:sldIdLst>
             <p14:sldId id="267"/>
             <p14:sldId id="268"/>
           </p14:sldIdLst>
         </p14:section>
-        <p14:section name="Secinājumi" id="{95ef4683-e5c6-473c-288c-c5a323eb78e6}">
+        <p14:section name="Secinājumi" id="{09874c85-ebe5-a676-43b5-f47b9ccdf756}">
           <p14:sldIdLst>
             <p14:sldId id="269"/>
           </p14:sldIdLst>
@@ -650,7 +650,7 @@
           <a:p>
             <a:r>
               <a:rPr lang="en-US" dirty="0"/>
-              <a:t>Svarīgākā mācība par pieejamību: zaļš axe nenozīmē piekļūstamu lapu. Pēc labojumiem abas pārbaudes ir zaļas.</a:t>
+              <a:t>Svarīgākā mācība par pieejamību: zaļš axe nenozīmē piekļūstamu lapu. Pēc labojumiem abas pārbaudes ir zaļas. Cilvēks noiet pilnu ceļu ar peli un tastatūru (iesniegums 2026-0011) un apstiprināja, ka viss bija skaidrs un ērts — tas ir pirmais pierādījums, ko nav veicis Claude.</a:t>
             </a:r>
             <a:endParaRPr lang="en-US" dirty="0"/>
           </a:p>
@@ -3263,6 +3263,24 @@
                   <a:schemeClr val="tx1"/>
                 </a:solidFill>
               </a:rPr>
+              <a:t>Cilvēka pieņemšanas tests (pele + tastatūra: iesniegt → apstrādāt ar MI projektu → pārbaudīt statusu): izdevās — «viss bija skaidrs un ērts»</a:t>
+            </a:r>
+            <a:endParaRPr lang="en-US" sz="1500" dirty="0"/>
+          </a:p>
+          <a:p>
+            <a:pPr marL="342900" indent="-342900">
+              <a:spcAft>
+                <a:spcPts val="800"/>
+              </a:spcAft>
+              <a:buSzPct val="100000"/>
+              <a:buChar char="•"/>
+            </a:pPr>
+            <a:r>
+              <a:rPr lang="en-US" sz="1500" dirty="0">
+                <a:solidFill>
+                  <a:schemeClr val="tx1"/>
+                </a:solidFill>
+              </a:rPr>
               <a:t>Ekrānlasītāja tests (NVDA) joprojām jāveic cilvēkam</a:t>
             </a:r>
             <a:endParaRPr lang="en-US" sz="1500" dirty="0"/>
@@ -11059,7 +11077,7 @@
                 <a:gridCol w="6675120"/>
                 <a:gridCol w="4389120"/>
               </a:tblGrid>
-              <a:tr h="566928">
+              <a:tr h="548640">
                 <a:tc>
                   <a:txBody>
                     <a:bodyPr/>
@@ -11183,7 +11201,7 @@
                   </a:tcPr>
                 </a:tc>
               </a:tr>
-              <a:tr h="566928">
+              <a:tr h="548640">
                 <a:tc>
                   <a:txBody>
                     <a:bodyPr/>
@@ -11307,7 +11325,7 @@
                   </a:tcPr>
                 </a:tc>
               </a:tr>
-              <a:tr h="566928">
+              <a:tr h="548640">
                 <a:tc>
                   <a:txBody>
                     <a:bodyPr/>
@@ -11431,7 +11449,7 @@
                   </a:tcPr>
                 </a:tc>
               </a:tr>
-              <a:tr h="566928">
+              <a:tr h="548640">
                 <a:tc>
                   <a:txBody>
                     <a:bodyPr/>
@@ -11555,7 +11573,131 @@
                   </a:tcPr>
                 </a:tc>
               </a:tr>
-              <a:tr h="566928">
+              <a:tr h="548640">
+                <a:tc>
+                  <a:txBody>
+                    <a:bodyPr/>
+                    <a:lstStyle/>
+                    <a:p>
+                      <a:pPr indent="0" marL="0">
+                        <a:buNone/>
+                      </a:pPr>
+                      <a:r>
+                        <a:rPr lang="en-US" sz="1600" dirty="0">
+                          <a:solidFill>
+                            <a:schemeClr val="tx1"/>
+                          </a:solidFill>
+                        </a:rPr>
+                        <a:t>Lietojamības pieņemšanas tests (pele + tastatūra)</a:t>
+                      </a:r>
+                      <a:endParaRPr lang="en-US" sz="1600" dirty="0"/>
+                    </a:p>
+                  </a:txBody>
+                  <a:tcPr marL="109728" marR="109728" marT="109728" marB="109728" anchor="ctr">
+                    <a:lnL w="9525" cap="flat" cmpd="sng" algn="ctr">
+                      <a:solidFill>
+                        <a:srgbClr val="C9D6DA"/>
+                      </a:solidFill>
+                      <a:prstDash val="solid"/>
+                      <a:round/>
+                      <a:headEnd type="none" w="med" len="med"/>
+                      <a:tailEnd type="none" w="med" len="med"/>
+                    </a:lnL>
+                    <a:lnR w="9525" cap="flat" cmpd="sng" algn="ctr">
+                      <a:solidFill>
+                        <a:srgbClr val="C9D6DA"/>
+                      </a:solidFill>
+                      <a:prstDash val="solid"/>
+                      <a:round/>
+                      <a:headEnd type="none" w="med" len="med"/>
+                      <a:tailEnd type="none" w="med" len="med"/>
+                    </a:lnR>
+                    <a:lnT w="9525" cap="flat" cmpd="sng" algn="ctr">
+                      <a:solidFill>
+                        <a:srgbClr val="C9D6DA"/>
+                      </a:solidFill>
+                      <a:prstDash val="solid"/>
+                      <a:round/>
+                      <a:headEnd type="none" w="med" len="med"/>
+                      <a:tailEnd type="none" w="med" len="med"/>
+                    </a:lnT>
+                    <a:lnB w="9525" cap="flat" cmpd="sng" algn="ctr">
+                      <a:solidFill>
+                        <a:srgbClr val="C9D6DA"/>
+                      </a:solidFill>
+                      <a:prstDash val="solid"/>
+                      <a:round/>
+                      <a:headEnd type="none" w="med" len="med"/>
+                      <a:tailEnd type="none" w="med" len="med"/>
+                    </a:lnB>
+                    <a:solidFill>
+                      <a:schemeClr val="bg1"/>
+                    </a:solidFill>
+                  </a:tcPr>
+                </a:tc>
+                <a:tc>
+                  <a:txBody>
+                    <a:bodyPr/>
+                    <a:lstStyle/>
+                    <a:p>
+                      <a:pPr indent="0" marL="0">
+                        <a:buNone/>
+                      </a:pPr>
+                      <a:r>
+                        <a:rPr lang="en-US" sz="1600" dirty="0">
+                          <a:solidFill>
+                            <a:schemeClr val="tx1"/>
+                          </a:solidFill>
+                        </a:rPr>
+                        <a:t>Cilvēks — izdevās 14.10.2026</a:t>
+                      </a:r>
+                      <a:endParaRPr lang="en-US" sz="1600" dirty="0"/>
+                    </a:p>
+                  </a:txBody>
+                  <a:tcPr marL="109728" marR="109728" marT="109728" marB="109728" anchor="ctr">
+                    <a:lnL w="9525" cap="flat" cmpd="sng" algn="ctr">
+                      <a:solidFill>
+                        <a:srgbClr val="C9D6DA"/>
+                      </a:solidFill>
+                      <a:prstDash val="solid"/>
+                      <a:round/>
+                      <a:headEnd type="none" w="med" len="med"/>
+                      <a:tailEnd type="none" w="med" len="med"/>
+                    </a:lnL>
+                    <a:lnR w="9525" cap="flat" cmpd="sng" algn="ctr">
+                      <a:solidFill>
+                        <a:srgbClr val="C9D6DA"/>
+                      </a:solidFill>
+                      <a:prstDash val="solid"/>
+                      <a:round/>
+                      <a:headEnd type="none" w="med" len="med"/>
+                      <a:tailEnd type="none" w="med" len="med"/>
+                    </a:lnR>
+                    <a:lnT w="9525" cap="flat" cmpd="sng" algn="ctr">
+                      <a:solidFill>
+                        <a:srgbClr val="C9D6DA"/>
+                      </a:solidFill>
+                      <a:prstDash val="solid"/>
+                      <a:round/>
+                      <a:headEnd type="none" w="med" len="med"/>
+                      <a:tailEnd type="none" w="med" len="med"/>
+                    </a:lnT>
+                    <a:lnB w="9525" cap="flat" cmpd="sng" algn="ctr">
+                      <a:solidFill>
+                        <a:srgbClr val="C9D6DA"/>
+                      </a:solidFill>
+                      <a:prstDash val="solid"/>
+                      <a:round/>
+                      <a:headEnd type="none" w="med" len="med"/>
+                      <a:tailEnd type="none" w="med" len="med"/>
+                    </a:lnB>
+                    <a:solidFill>
+                      <a:schemeClr val="bg1"/>
+                    </a:solidFill>
+                  </a:tcPr>
+                </a:tc>
+              </a:tr>
+              <a:tr h="548640">
                 <a:tc>
                   <a:txBody>
                     <a:bodyPr/>
@@ -11679,7 +11821,7 @@
                   </a:tcPr>
                 </a:tc>
               </a:tr>
-              <a:tr h="566928">
+              <a:tr h="548640">
                 <a:tc>
                   <a:txBody>
                     <a:bodyPr/>
@@ -11815,8 +11957,8 @@
         </p:nvSpPr>
         <p:spPr>
           <a:xfrm>
-            <a:off x="548640" y="5257800"/>
-            <a:ext cx="11064240" cy="822960"/>
+            <a:off x="548640" y="5623560"/>
+            <a:ext cx="11064240" cy="685800"/>
           </a:xfrm>
           <a:prstGeom prst="rect">
             <a:avLst/>

</xml_diff>